<commit_message>
Update training and help docs for the rebuilt admin pages
</commit_message>
<xml_diff>
--- a/docs/training/ePT-Training-Curriculum.pptx
+++ b/docs/training/ePT-Training-Curriculum.pptx
@@ -16399,7 +16399,7 @@
                 <a:ea typeface="Calibri" pitchFamily="34" charset="-122"/>
                 <a:cs typeface="Calibri" pitchFamily="34" charset="-120"/>
               </a:rPr>
-              <a:t>Go to Configure → PT Participants → Add</a:t>
+              <a:t>Go to Configure → PT Participants → Add New Participant</a:t>
             </a:r>
             <a:endParaRPr lang="en-US" sz="1300" dirty="0"/>
           </a:p>
@@ -16584,7 +16584,7 @@
                 <a:ea typeface="Calibri" pitchFamily="34" charset="-122"/>
                 <a:cs typeface="Calibri" pitchFamily="34" charset="-120"/>
               </a:rPr>
-              <a:t>Configure → Bulk Import Participants</a:t>
+              <a:t>Configure → PT Participants → Bulk Import Participants</a:t>
             </a:r>
             <a:endParaRPr lang="en-US" sz="1300" dirty="0"/>
           </a:p>
@@ -17091,7 +17091,7 @@
                 <a:ea typeface="Calibri" pitchFamily="34" charset="-122"/>
                 <a:cs typeface="Calibri" pitchFamily="34" charset="-120"/>
               </a:rPr>
-              <a:t>Select the scheme type from the dropdown (e.g., HIV Serology)</a:t>
+              <a:t>On the Lists tab, find the scheme (e.g., HIV Serology)</a:t>
             </a:r>
             <a:endParaRPr lang="en-US" sz="1400" dirty="0"/>
           </a:p>
@@ -17196,7 +17196,7 @@
                 <a:ea typeface="Calibri" pitchFamily="34" charset="-122"/>
                 <a:cs typeface="Calibri" pitchFamily="34" charset="-120"/>
               </a:rPr>
-              <a:t>Click on the relevant scheme enrollment link</a:t>
+              <a:t>Click Edit on the scheme's Default list</a:t>
             </a:r>
             <a:endParaRPr lang="en-US" sz="1400" dirty="0"/>
           </a:p>
@@ -17301,7 +17301,7 @@
                 <a:ea typeface="Calibri" pitchFamily="34" charset="-122"/>
                 <a:cs typeface="Calibri" pitchFamily="34" charset="-120"/>
               </a:rPr>
-              <a:t>Move participants from the Available list (left) to the Enrolled list (right)</a:t>
+              <a:t>Click participants in Not on this list (left) to move them to On this list (right)</a:t>
             </a:r>
             <a:endParaRPr lang="en-US" sz="1400" dirty="0"/>
           </a:p>
@@ -17406,7 +17406,7 @@
                 <a:ea typeface="Calibri" pitchFamily="34" charset="-122"/>
                 <a:cs typeface="Calibri" pitchFamily="34" charset="-120"/>
               </a:rPr>
-              <a:t>Click Enroll Selected to save</a:t>
+              <a:t>Click Save changes</a:t>
             </a:r>
             <a:endParaRPr lang="en-US" sz="1400" dirty="0"/>
           </a:p>

</xml_diff>